<commit_message>
Turtle lesson: add bonus game slide, fix slide 6 angle typo, instant jumps in turtle_game.py
Co-Authored-By: Claude Opus 5.5 <noreply@anthropic.com>
Claude-Session: https://claude.ai/code/session_01Kfjxy5J63JtXFkESQ2saD6
</commit_message>
<xml_diff>
--- a/lesson2 turtle/שיעור הצב המצייר.pptx
+++ b/lesson2 turtle/שיעור הצב המצייר.pptx
@@ -22,6 +22,7 @@
     <p:sldId id="267" r:id="rId13"/>
     <p:sldId id="268" r:id="rId14"/>
     <p:sldId id="269" r:id="rId15"/>
+    <p:sldId id="271" r:id="rId22"/>
     <p:sldId id="270" r:id="rId16"/>
   </p:sldIdLst>
   <p:sldSz cx="12192000" cy="6858000"/>
@@ -903,6 +904,87 @@
 </p:notes>
 </file>
 
+<file path=ppt/notesSlides/notesSlide16.xml><?xml version="1.0" encoding="utf-8"?>
+<p:notes xmlns:a="http://schemas.openxmlformats.org/drawingml/2006/main" xmlns:p="http://schemas.openxmlformats.org/presentationml/2006/main" xmlns:r="http://schemas.openxmlformats.org/officeDocument/2006/relationships">
+  <p:cSld>
+    <p:spTree>
+      <p:nvGrpSpPr>
+        <p:cNvPr id="1" name=""/>
+        <p:cNvGrpSpPr/>
+        <p:nvPr/>
+      </p:nvGrpSpPr>
+      <p:grpSpPr>
+        <a:xfrm>
+          <a:off x="0" y="0"/>
+          <a:ext cx="0" cy="0"/>
+          <a:chOff x="0" y="0"/>
+          <a:chExt cx="0" cy="0"/>
+        </a:xfrm>
+      </p:grpSpPr>
+      <p:sp>
+        <p:nvSpPr>
+          <p:cNvPr id="2" name="Slide Image Placeholder 1"/>
+          <p:cNvSpPr>
+            <a:spLocks noGrp="1" noRot="1" noChangeAspect="1"/>
+          </p:cNvSpPr>
+          <p:nvPr>
+            <p:ph type="sldImg"/>
+          </p:nvPr>
+        </p:nvSpPr>
+        <p:spPr/>
+      </p:sp>
+      <p:sp>
+        <p:nvSpPr>
+          <p:cNvPr id="3" name="Notes Placeholder 2"/>
+          <p:cNvSpPr>
+            <a:spLocks noGrp="1"/>
+          </p:cNvSpPr>
+          <p:nvPr>
+            <p:ph type="body" idx="1"/>
+          </p:nvPr>
+        </p:nvSpPr>
+        <p:spPr/>
+        <p:txBody>
+          <a:bodyPr/>
+          <a:lstStyle/>
+          <a:p>
+            <a:r>
+              <a:t>4 דק'. הדגמה בלבד - לא צריך להבין כל שורה. turtle7.py: תנו לתלמיד לשלוט בצב מול הכיתה. turtle_game.py: תחרות קצרה - מי מגיע לניקוד הגבוה ביותר. פקודות חדשות: onkey, onclick, ontimer ו-def (פונקציה) - נלמד בהמשך.</a:t>
+            </a:r>
+          </a:p>
+        </p:txBody>
+      </p:sp>
+      <p:sp>
+        <p:nvSpPr>
+          <p:cNvPr id="4" name="Slide Number Placeholder 3"/>
+          <p:cNvSpPr>
+            <a:spLocks noGrp="1"/>
+          </p:cNvSpPr>
+          <p:nvPr>
+            <p:ph type="sldNum" sz="quarter" idx="10"/>
+          </p:nvPr>
+        </p:nvSpPr>
+        <p:spPr/>
+        <p:txBody>
+          <a:bodyPr/>
+          <a:lstStyle/>
+          <a:p>
+            <a:fld id="{F7021451-1387-4CA6-816F-3879F97B5CBC}" type="slidenum">
+              <a:rPr lang="en-US"/>
+              <a:t>12</a:t>
+            </a:fld>
+            <a:endParaRPr lang="en-US"/>
+          </a:p>
+        </p:txBody>
+      </p:sp>
+    </p:spTree>
+  </p:cSld>
+  <p:clrMapOvr>
+    <a:masterClrMapping/>
+  </p:clrMapOvr>
+</p:notes>
+</file>
+
 <file path=ppt/notesSlides/notesSlide2.xml><?xml version="1.0" encoding="utf-8"?>
 <p:notes xmlns:a="http://schemas.openxmlformats.org/drawingml/2006/main" xmlns:r="http://schemas.openxmlformats.org/officeDocument/2006/relationships" xmlns:p="http://schemas.openxmlformats.org/presentationml/2006/main">
   <p:cSld>
@@ -1296,8 +1378,7 @@
           <a:lstStyle/>
           <a:p>
             <a:r>
-              <a:rPr lang="en-US" dirty="0"/>
-              <a:t>4 דק'. בקשו מתלמיד לקום ולהיות 'הצב' - הכיתה נותנת לו פקודות. תשובת החידה: משולש שווה צלעות. left = שמאלה, right = ימינה.</a:t>
+              <a:t>4 דק'. בקשו מתלמיד לקום ולהיות 'הצב' - הכיתה נותנת לו פקודות. תשובת החידה: משולש שווה צלעות. left = שמאלה, right = ימינה. שימו לב: הזווית בתוך משולש שווה צלעות היא 60, אבל הצב מסתובב 120 (180 פחות 60). בריבוע שתיהן 90 ולכן זה לא מבלבל.</a:t>
             </a:r>
           </a:p>
         </p:txBody>
@@ -9305,6 +9386,551 @@
 </p:sld>
 </file>
 
+<file path=ppt/slides/slide16.xml><?xml version="1.0" encoding="utf-8"?>
+<p:sld xmlns:a="http://schemas.openxmlformats.org/drawingml/2006/main" xmlns:p="http://schemas.openxmlformats.org/presentationml/2006/main" xmlns:r="http://schemas.openxmlformats.org/officeDocument/2006/relationships">
+  <p:cSld>
+    <p:spTree>
+      <p:nvGrpSpPr>
+        <p:cNvPr id="1" name=""/>
+        <p:cNvGrpSpPr/>
+        <p:nvPr/>
+      </p:nvGrpSpPr>
+      <p:grpSpPr/>
+      <p:sp>
+        <p:nvSpPr>
+          <p:cNvPr id="2" name="Text 0"/>
+          <p:cNvSpPr>
+            <a:spLocks noGrp="1"/>
+          </p:cNvSpPr>
+          <p:nvPr>
+            <p:ph type="title" idx="100" hasCustomPrompt="1"/>
+          </p:nvPr>
+        </p:nvSpPr>
+        <p:spPr>
+          <a:xfrm>
+            <a:off x="548640" y="274320"/>
+            <a:ext cx="11091672" cy="822960"/>
+          </a:xfrm>
+          <a:prstGeom prst="rect">
+            <a:avLst/>
+          </a:prstGeom>
+          <a:noFill/>
+          <a:ln/>
+        </p:spPr>
+        <p:txBody>
+          <a:bodyPr wrap="square" lIns="0" tIns="0" rIns="0" bIns="0" rtlCol="0" anchor="ctr"/>
+          <a:lstStyle/>
+          <a:p>
+            <a:pPr marL="0" indent="0" algn="r" rtl="1">
+              <a:buNone/>
+            </a:pPr>
+            <a:r>
+              <a:rPr lang="en-US" sz="3600" b="1" dirty="0" err="1">
+                <a:solidFill>
+                  <a:schemeClr val="tx2"/>
+                </a:solidFill>
+              </a:rPr>
+              <a:t>בונוס: הצב יודע גם לשחק!</a:t>
+            </a:r>
+            <a:endParaRPr lang="en-US" sz="3600" dirty="0"/>
+          </a:p>
+        </p:txBody>
+      </p:sp>
+      <p:sp>
+        <p:nvSpPr>
+          <p:cNvPr id="2" name="Title 1"/>
+          <p:cNvSpPr>
+            <a:spLocks noGrp="1"/>
+          </p:cNvSpPr>
+          <p:nvPr>
+            <p:ph type="title" idx="100"/>
+          </p:nvPr>
+        </p:nvSpPr>
+        <p:spPr/>
+        <p:txBody>
+          <a:bodyPr/>
+          <a:lstStyle/>
+          <a:p/>
+        </p:txBody>
+      </p:sp>
+      <p:sp>
+        <p:nvSpPr>
+          <p:cNvPr id="3" name="Rounded Rectangle 2"/>
+          <p:cNvSpPr/>
+          <p:nvPr/>
+        </p:nvSpPr>
+        <p:spPr>
+          <a:xfrm>
+            <a:off x="6336792" y="1325880"/>
+            <a:ext cx="5303520" cy="2971800"/>
+          </a:xfrm>
+          <a:prstGeom prst="roundRect">
+            <a:avLst>
+              <a:gd name="adj" fmla="val 8000"/>
+            </a:avLst>
+          </a:prstGeom>
+          <a:solidFill>
+            <a:srgbClr val="FFFFFF"/>
+          </a:solidFill>
+          <a:ln w="12700">
+            <a:solidFill>
+              <a:srgbClr val="D8E8DE"/>
+            </a:solidFill>
+          </a:ln>
+          <a:effectLst/>
+        </p:spPr>
+        <p:style>
+          <a:lnRef idx="1">
+            <a:schemeClr val="accent1"/>
+          </a:lnRef>
+          <a:fillRef idx="3">
+            <a:schemeClr val="accent1"/>
+          </a:fillRef>
+          <a:effectRef idx="2">
+            <a:schemeClr val="accent1"/>
+          </a:effectRef>
+          <a:fontRef idx="minor">
+            <a:schemeClr val="lt1"/>
+          </a:fontRef>
+        </p:style>
+        <p:txBody>
+          <a:bodyPr rtlCol="0" anchor="ctr"/>
+          <a:lstStyle/>
+          <a:p/>
+        </p:txBody>
+      </p:sp>
+      <p:pic>
+        <p:nvPicPr>
+          <p:cNvPr id="4" name="Picture 3" descr="keysc.png"/>
+          <p:cNvPicPr>
+            <a:picLocks noChangeAspect="1"/>
+          </p:cNvPicPr>
+          <p:nvPr/>
+        </p:nvPicPr>
+        <p:blipFill>
+          <a:blip r:embed="rId2"/>
+          <a:stretch>
+            <a:fillRect/>
+          </a:stretch>
+        </p:blipFill>
+        <p:spPr>
+          <a:xfrm>
+            <a:off x="7296912" y="1463040"/>
+            <a:ext cx="3379154" cy="2697480"/>
+          </a:xfrm>
+          <a:prstGeom prst="rect">
+            <a:avLst/>
+          </a:prstGeom>
+        </p:spPr>
+      </p:pic>
+      <p:sp>
+        <p:nvSpPr>
+          <p:cNvPr id="5" name="TextBox 4"/>
+          <p:cNvSpPr txBox="1"/>
+          <p:nvPr/>
+        </p:nvSpPr>
+        <p:spPr>
+          <a:xfrm>
+            <a:off x="6336792" y="4434840"/>
+            <a:ext cx="5303520" cy="457200"/>
+          </a:xfrm>
+          <a:prstGeom prst="rect">
+            <a:avLst/>
+          </a:prstGeom>
+          <a:noFill/>
+        </p:spPr>
+        <p:txBody>
+          <a:bodyPr wrap="square" anchor="t" lIns="0" rIns="0" tIns="0" bIns="0">
+            <a:spAutoFit/>
+          </a:bodyPr>
+          <a:lstStyle/>
+          <a:p>
+            <a:pPr algn="r" rtl="1">
+              <a:spcAft>
+                <a:spcPts val="400"/>
+              </a:spcAft>
+            </a:pPr>
+            <a:r>
+              <a:rPr sz="2200" b="1">
+                <a:solidFill>
+                  <a:srgbClr val="2D9F5C"/>
+                </a:solidFill>
+                <a:latin typeface="Arial"/>
+              </a:rPr>
+              <a:t>ציור עם המקלדת</a:t>
+            </a:r>
+          </a:p>
+        </p:txBody>
+      </p:sp>
+      <p:sp>
+        <p:nvSpPr>
+          <p:cNvPr id="6" name="TextBox 5"/>
+          <p:cNvSpPr txBox="1"/>
+          <p:nvPr/>
+        </p:nvSpPr>
+        <p:spPr>
+          <a:xfrm>
+            <a:off x="6336792" y="4892040"/>
+            <a:ext cx="5303520" cy="914400"/>
+          </a:xfrm>
+          <a:prstGeom prst="rect">
+            <a:avLst/>
+          </a:prstGeom>
+          <a:noFill/>
+        </p:spPr>
+        <p:txBody>
+          <a:bodyPr wrap="square" anchor="t" lIns="0" rIns="0" tIns="0" bIns="0">
+            <a:spAutoFit/>
+          </a:bodyPr>
+          <a:lstStyle/>
+          <a:p>
+            <a:pPr algn="r" rtl="1">
+              <a:spcAft>
+                <a:spcPts val="400"/>
+              </a:spcAft>
+            </a:pPr>
+            <a:r>
+              <a:rPr sz="1600" b="0">
+                <a:solidFill>
+                  <a:srgbClr val="1B2B34"/>
+                </a:solidFill>
+                <a:latin typeface="Arial"/>
+              </a:rPr>
+              <a:t>חיצים - הזזת הצב</a:t>
+            </a:r>
+          </a:p>
+          <a:p>
+            <a:pPr algn="r" rtl="1">
+              <a:spcAft>
+                <a:spcPts val="400"/>
+              </a:spcAft>
+            </a:pPr>
+            <a:r>
+              <a:rPr sz="1600" b="0">
+                <a:solidFill>
+                  <a:srgbClr val="1B2B34"/>
+                </a:solidFill>
+                <a:latin typeface="Arial"/>
+              </a:rPr>
+              <a:t>רווח - הרמת / הורדת העט</a:t>
+            </a:r>
+          </a:p>
+          <a:p>
+            <a:pPr algn="r" rtl="1">
+              <a:spcAft>
+                <a:spcPts val="400"/>
+              </a:spcAft>
+            </a:pPr>
+            <a:r>
+              <a:rPr sz="1600" b="0">
+                <a:solidFill>
+                  <a:srgbClr val="1B2B34"/>
+                </a:solidFill>
+                <a:latin typeface="Arial"/>
+              </a:rPr>
+              <a:t>c - מחיקת הציור</a:t>
+            </a:r>
+          </a:p>
+        </p:txBody>
+      </p:sp>
+      <p:sp>
+        <p:nvSpPr>
+          <p:cNvPr id="7" name="Rounded Rectangle 6"/>
+          <p:cNvSpPr/>
+          <p:nvPr/>
+        </p:nvSpPr>
+        <p:spPr>
+          <a:xfrm>
+            <a:off x="9262872" y="5806440"/>
+            <a:ext cx="2377440" cy="457200"/>
+          </a:xfrm>
+          <a:prstGeom prst="roundRect">
+            <a:avLst>
+              <a:gd name="adj" fmla="val 50000"/>
+            </a:avLst>
+          </a:prstGeom>
+          <a:solidFill>
+            <a:srgbClr val="FF9F1C"/>
+          </a:solidFill>
+          <a:ln>
+            <a:noFill/>
+          </a:ln>
+          <a:effectLst/>
+        </p:spPr>
+        <p:style>
+          <a:lnRef idx="1">
+            <a:schemeClr val="accent1"/>
+          </a:lnRef>
+          <a:fillRef idx="3">
+            <a:schemeClr val="accent1"/>
+          </a:fillRef>
+          <a:effectRef idx="2">
+            <a:schemeClr val="accent1"/>
+          </a:effectRef>
+          <a:fontRef idx="minor">
+            <a:schemeClr val="lt1"/>
+          </a:fontRef>
+        </p:style>
+        <p:txBody>
+          <a:bodyPr rtlCol="0" anchor="ctr" lIns="0" rIns="0"/>
+          <a:lstStyle/>
+          <a:p>
+            <a:pPr algn="ctr"/>
+            <a:r>
+              <a:rPr sz="1600" b="1">
+                <a:solidFill>
+                  <a:srgbClr val="FFFFFF"/>
+                </a:solidFill>
+                <a:latin typeface="Arial"/>
+              </a:rPr>
+              <a:t>turtle7.py</a:t>
+            </a:r>
+          </a:p>
+        </p:txBody>
+      </p:sp>
+      <p:sp>
+        <p:nvSpPr>
+          <p:cNvPr id="8" name="Rounded Rectangle 7"/>
+          <p:cNvSpPr/>
+          <p:nvPr/>
+        </p:nvSpPr>
+        <p:spPr>
+          <a:xfrm>
+            <a:off x="548640" y="1325880"/>
+            <a:ext cx="5303520" cy="2971800"/>
+          </a:xfrm>
+          <a:prstGeom prst="roundRect">
+            <a:avLst>
+              <a:gd name="adj" fmla="val 8000"/>
+            </a:avLst>
+          </a:prstGeom>
+          <a:solidFill>
+            <a:srgbClr val="FFFFFF"/>
+          </a:solidFill>
+          <a:ln w="12700">
+            <a:solidFill>
+              <a:srgbClr val="D8E8DE"/>
+            </a:solidFill>
+          </a:ln>
+          <a:effectLst/>
+        </p:spPr>
+        <p:style>
+          <a:lnRef idx="1">
+            <a:schemeClr val="accent1"/>
+          </a:lnRef>
+          <a:fillRef idx="3">
+            <a:schemeClr val="accent1"/>
+          </a:fillRef>
+          <a:effectRef idx="2">
+            <a:schemeClr val="accent1"/>
+          </a:effectRef>
+          <a:fontRef idx="minor">
+            <a:schemeClr val="lt1"/>
+          </a:fontRef>
+        </p:style>
+        <p:txBody>
+          <a:bodyPr rtlCol="0" anchor="ctr"/>
+          <a:lstStyle/>
+          <a:p/>
+        </p:txBody>
+      </p:sp>
+      <p:pic>
+        <p:nvPicPr>
+          <p:cNvPr id="9" name="Picture 8" descr="game_midc.png"/>
+          <p:cNvPicPr>
+            <a:picLocks noChangeAspect="1"/>
+          </p:cNvPicPr>
+          <p:nvPr/>
+        </p:nvPicPr>
+        <p:blipFill>
+          <a:blip r:embed="rId3"/>
+          <a:stretch>
+            <a:fillRect/>
+          </a:stretch>
+        </p:blipFill>
+        <p:spPr>
+          <a:xfrm>
+            <a:off x="1508760" y="1463040"/>
+            <a:ext cx="3379154" cy="2697480"/>
+          </a:xfrm>
+          <a:prstGeom prst="rect">
+            <a:avLst/>
+          </a:prstGeom>
+        </p:spPr>
+      </p:pic>
+      <p:sp>
+        <p:nvSpPr>
+          <p:cNvPr id="10" name="TextBox 9"/>
+          <p:cNvSpPr txBox="1"/>
+          <p:nvPr/>
+        </p:nvSpPr>
+        <p:spPr>
+          <a:xfrm>
+            <a:off x="548640" y="4434840"/>
+            <a:ext cx="5303520" cy="457200"/>
+          </a:xfrm>
+          <a:prstGeom prst="rect">
+            <a:avLst/>
+          </a:prstGeom>
+          <a:noFill/>
+        </p:spPr>
+        <p:txBody>
+          <a:bodyPr wrap="square" anchor="t" lIns="0" rIns="0" tIns="0" bIns="0">
+            <a:spAutoFit/>
+          </a:bodyPr>
+          <a:lstStyle/>
+          <a:p>
+            <a:pPr algn="r" rtl="1">
+              <a:spcAft>
+                <a:spcPts val="400"/>
+              </a:spcAft>
+            </a:pPr>
+            <a:r>
+              <a:rPr sz="2200" b="1">
+                <a:solidFill>
+                  <a:srgbClr val="EF476F"/>
+                </a:solidFill>
+                <a:latin typeface="Arial"/>
+              </a:rPr>
+              <a:t>משחק: תפסו את הצב!</a:t>
+            </a:r>
+          </a:p>
+        </p:txBody>
+      </p:sp>
+      <p:sp>
+        <p:nvSpPr>
+          <p:cNvPr id="11" name="TextBox 10"/>
+          <p:cNvSpPr txBox="1"/>
+          <p:nvPr/>
+        </p:nvSpPr>
+        <p:spPr>
+          <a:xfrm>
+            <a:off x="548640" y="4892040"/>
+            <a:ext cx="5303520" cy="914400"/>
+          </a:xfrm>
+          <a:prstGeom prst="rect">
+            <a:avLst/>
+          </a:prstGeom>
+          <a:noFill/>
+        </p:spPr>
+        <p:txBody>
+          <a:bodyPr wrap="square" anchor="t" lIns="0" rIns="0" tIns="0" bIns="0">
+            <a:spAutoFit/>
+          </a:bodyPr>
+          <a:lstStyle/>
+          <a:p>
+            <a:pPr algn="r" rtl="1">
+              <a:spcAft>
+                <a:spcPts val="400"/>
+              </a:spcAft>
+            </a:pPr>
+            <a:r>
+              <a:rPr sz="1600" b="0">
+                <a:solidFill>
+                  <a:srgbClr val="1B2B34"/>
+                </a:solidFill>
+                <a:latin typeface="Arial"/>
+              </a:rPr>
+              <a:t>לחיצה על הצב - נקודה</a:t>
+            </a:r>
+          </a:p>
+          <a:p>
+            <a:pPr algn="r" rtl="1">
+              <a:spcAft>
+                <a:spcPts val="400"/>
+              </a:spcAft>
+            </a:pPr>
+            <a:r>
+              <a:rPr sz="1600" b="0">
+                <a:solidFill>
+                  <a:srgbClr val="1B2B34"/>
+                </a:solidFill>
+                <a:latin typeface="Arial"/>
+              </a:rPr>
+              <a:t>יש לכם 30 שניות</a:t>
+            </a:r>
+          </a:p>
+          <a:p>
+            <a:pPr algn="r" rtl="1">
+              <a:spcAft>
+                <a:spcPts val="400"/>
+              </a:spcAft>
+            </a:pPr>
+            <a:r>
+              <a:rPr sz="1600" b="0">
+                <a:solidFill>
+                  <a:srgbClr val="1B2B34"/>
+                </a:solidFill>
+                <a:latin typeface="Arial"/>
+              </a:rPr>
+              <a:t>כמה תצליחו לצבור?</a:t>
+            </a:r>
+          </a:p>
+        </p:txBody>
+      </p:sp>
+      <p:sp>
+        <p:nvSpPr>
+          <p:cNvPr id="12" name="Rounded Rectangle 11"/>
+          <p:cNvSpPr/>
+          <p:nvPr/>
+        </p:nvSpPr>
+        <p:spPr>
+          <a:xfrm>
+            <a:off x="3474719" y="5806440"/>
+            <a:ext cx="2377440" cy="457200"/>
+          </a:xfrm>
+          <a:prstGeom prst="roundRect">
+            <a:avLst>
+              <a:gd name="adj" fmla="val 50000"/>
+            </a:avLst>
+          </a:prstGeom>
+          <a:solidFill>
+            <a:srgbClr val="FF9F1C"/>
+          </a:solidFill>
+          <a:ln>
+            <a:noFill/>
+          </a:ln>
+          <a:effectLst/>
+        </p:spPr>
+        <p:style>
+          <a:lnRef idx="1">
+            <a:schemeClr val="accent1"/>
+          </a:lnRef>
+          <a:fillRef idx="3">
+            <a:schemeClr val="accent1"/>
+          </a:fillRef>
+          <a:effectRef idx="2">
+            <a:schemeClr val="accent1"/>
+          </a:effectRef>
+          <a:fontRef idx="minor">
+            <a:schemeClr val="lt1"/>
+          </a:fontRef>
+        </p:style>
+        <p:txBody>
+          <a:bodyPr rtlCol="0" anchor="ctr" lIns="0" rIns="0"/>
+          <a:lstStyle/>
+          <a:p>
+            <a:pPr algn="ctr"/>
+            <a:r>
+              <a:rPr sz="1600" b="1">
+                <a:solidFill>
+                  <a:srgbClr val="FFFFFF"/>
+                </a:solidFill>
+                <a:latin typeface="Arial"/>
+              </a:rPr>
+              <a:t>turtle_game.py</a:t>
+            </a:r>
+          </a:p>
+        </p:txBody>
+      </p:sp>
+    </p:spTree>
+  </p:cSld>
+  <p:clrMapOvr>
+    <a:masterClrMapping/>
+  </p:clrMapOvr>
+</p:sld>
+</file>
+
 <file path=ppt/slides/slide2.xml><?xml version="1.0" encoding="utf-8"?>
 <p:sld xmlns:a="http://schemas.openxmlformats.org/drawingml/2006/main" xmlns:r="http://schemas.openxmlformats.org/officeDocument/2006/relationships" xmlns:p="http://schemas.openxmlformats.org/presentationml/2006/main">
   <p:cSld name="Slide 2">
@@ -13289,6 +13915,10 @@
             <a:prstDash val="solid"/>
           </a:ln>
         </p:spPr>
+        <p:txBody>
+          <a:bodyPr/>
+          <a:p/>
+        </p:txBody>
       </p:sp>
       <p:sp>
         <p:nvSpPr>
@@ -13388,6 +14018,10 @@
             <a:prstDash val="solid"/>
           </a:ln>
         </p:spPr>
+        <p:txBody>
+          <a:bodyPr/>
+          <a:p/>
+        </p:txBody>
       </p:sp>
       <p:sp>
         <p:nvSpPr>
@@ -13469,7 +14103,7 @@
             </a:pPr>
             <a:r>
               <a:rPr lang="en-US" dirty="0"/>
-              <a:t>3 * 130 = 360</a:t>
+              <a:t>3 * 120 = 360</a:t>
             </a:r>
             <a:endParaRPr lang="he-IL" sz="1800" dirty="0"/>
           </a:p>
@@ -13501,6 +14135,10 @@
             <a:prstDash val="solid"/>
           </a:ln>
         </p:spPr>
+        <p:txBody>
+          <a:bodyPr/>
+          <a:p/>
+        </p:txBody>
       </p:sp>
       <p:sp>
         <p:nvSpPr>
@@ -13600,6 +14238,10 @@
             <a:prstDash val="solid"/>
           </a:ln>
         </p:spPr>
+        <p:txBody>
+          <a:bodyPr/>
+          <a:p/>
+        </p:txBody>
       </p:sp>
       <p:sp>
         <p:nvSpPr>
@@ -13699,6 +14341,10 @@
             <a:prstDash val="solid"/>
           </a:ln>
         </p:spPr>
+        <p:txBody>
+          <a:bodyPr/>
+          <a:p/>
+        </p:txBody>
       </p:sp>
       <p:sp>
         <p:nvSpPr>
@@ -13724,6 +14370,10 @@
             <a:prstDash val="solid"/>
           </a:ln>
         </p:spPr>
+        <p:txBody>
+          <a:bodyPr/>
+          <a:p/>
+        </p:txBody>
       </p:sp>
       <p:pic>
         <p:nvPicPr>
@@ -13854,6 +14504,10 @@
             </a:outerShdw>
           </a:effectLst>
         </p:spPr>
+        <p:txBody>
+          <a:bodyPr/>
+          <a:p/>
+        </p:txBody>
       </p:sp>
       <p:sp>
         <p:nvSpPr>

</xml_diff>